<commit_message>
add a play ground of the h20.py in a jupiter notebook
</commit_message>
<xml_diff>
--- a/resource/Presentation1.pptx
+++ b/resource/Presentation1.pptx
@@ -7,6 +7,8 @@
   <p:sldIdLst>
     <p:sldId id="256" r:id="rId2"/>
     <p:sldId id="257" r:id="rId3"/>
+    <p:sldId id="258" r:id="rId4"/>
+    <p:sldId id="259" r:id="rId5"/>
   </p:sldIdLst>
   <p:sldSz cx="12192000" cy="6858000"/>
   <p:notesSz cx="6858000" cy="9144000"/>
@@ -105,6 +107,11 @@
       </a:defRPr>
     </a:lvl9pPr>
   </p:defaultTextStyle>
+  <p:extLst>
+    <p:ext uri="{EFAFB233-063F-42B5-8137-9DF3F51BA10A}">
+      <p15:sldGuideLst xmlns:p15="http://schemas.microsoft.com/office/powerpoint/2012/main"/>
+    </p:ext>
+  </p:extLst>
 </p:presentation>
 </file>
 
@@ -255,7 +262,7 @@
           <a:p>
             <a:fld id="{56A3A75C-D4C4-489F-B921-CA348B716ACA}" type="datetimeFigureOut">
               <a:rPr lang="en-US" smtClean="0"/>
-              <a:t>4/7/2026</a:t>
+              <a:t>4/8/2026</a:t>
             </a:fld>
             <a:endParaRPr lang="en-US"/>
           </a:p>
@@ -453,7 +460,7 @@
           <a:p>
             <a:fld id="{56A3A75C-D4C4-489F-B921-CA348B716ACA}" type="datetimeFigureOut">
               <a:rPr lang="en-US" smtClean="0"/>
-              <a:t>4/7/2026</a:t>
+              <a:t>4/8/2026</a:t>
             </a:fld>
             <a:endParaRPr lang="en-US"/>
           </a:p>
@@ -661,7 +668,7 @@
           <a:p>
             <a:fld id="{56A3A75C-D4C4-489F-B921-CA348B716ACA}" type="datetimeFigureOut">
               <a:rPr lang="en-US" smtClean="0"/>
-              <a:t>4/7/2026</a:t>
+              <a:t>4/8/2026</a:t>
             </a:fld>
             <a:endParaRPr lang="en-US"/>
           </a:p>
@@ -859,7 +866,7 @@
           <a:p>
             <a:fld id="{56A3A75C-D4C4-489F-B921-CA348B716ACA}" type="datetimeFigureOut">
               <a:rPr lang="en-US" smtClean="0"/>
-              <a:t>4/7/2026</a:t>
+              <a:t>4/8/2026</a:t>
             </a:fld>
             <a:endParaRPr lang="en-US"/>
           </a:p>
@@ -1134,7 +1141,7 @@
           <a:p>
             <a:fld id="{56A3A75C-D4C4-489F-B921-CA348B716ACA}" type="datetimeFigureOut">
               <a:rPr lang="en-US" smtClean="0"/>
-              <a:t>4/7/2026</a:t>
+              <a:t>4/8/2026</a:t>
             </a:fld>
             <a:endParaRPr lang="en-US"/>
           </a:p>
@@ -1399,7 +1406,7 @@
           <a:p>
             <a:fld id="{56A3A75C-D4C4-489F-B921-CA348B716ACA}" type="datetimeFigureOut">
               <a:rPr lang="en-US" smtClean="0"/>
-              <a:t>4/7/2026</a:t>
+              <a:t>4/8/2026</a:t>
             </a:fld>
             <a:endParaRPr lang="en-US"/>
           </a:p>
@@ -1811,7 +1818,7 @@
           <a:p>
             <a:fld id="{56A3A75C-D4C4-489F-B921-CA348B716ACA}" type="datetimeFigureOut">
               <a:rPr lang="en-US" smtClean="0"/>
-              <a:t>4/7/2026</a:t>
+              <a:t>4/8/2026</a:t>
             </a:fld>
             <a:endParaRPr lang="en-US"/>
           </a:p>
@@ -1952,7 +1959,7 @@
           <a:p>
             <a:fld id="{56A3A75C-D4C4-489F-B921-CA348B716ACA}" type="datetimeFigureOut">
               <a:rPr lang="en-US" smtClean="0"/>
-              <a:t>4/7/2026</a:t>
+              <a:t>4/8/2026</a:t>
             </a:fld>
             <a:endParaRPr lang="en-US"/>
           </a:p>
@@ -2065,7 +2072,7 @@
           <a:p>
             <a:fld id="{56A3A75C-D4C4-489F-B921-CA348B716ACA}" type="datetimeFigureOut">
               <a:rPr lang="en-US" smtClean="0"/>
-              <a:t>4/7/2026</a:t>
+              <a:t>4/8/2026</a:t>
             </a:fld>
             <a:endParaRPr lang="en-US"/>
           </a:p>
@@ -2376,7 +2383,7 @@
           <a:p>
             <a:fld id="{56A3A75C-D4C4-489F-B921-CA348B716ACA}" type="datetimeFigureOut">
               <a:rPr lang="en-US" smtClean="0"/>
-              <a:t>4/7/2026</a:t>
+              <a:t>4/8/2026</a:t>
             </a:fld>
             <a:endParaRPr lang="en-US"/>
           </a:p>
@@ -2664,7 +2671,7 @@
           <a:p>
             <a:fld id="{56A3A75C-D4C4-489F-B921-CA348B716ACA}" type="datetimeFigureOut">
               <a:rPr lang="en-US" smtClean="0"/>
-              <a:t>4/7/2026</a:t>
+              <a:t>4/8/2026</a:t>
             </a:fld>
             <a:endParaRPr lang="en-US"/>
           </a:p>
@@ -2905,7 +2912,7 @@
           <a:p>
             <a:fld id="{56A3A75C-D4C4-489F-B921-CA348B716ACA}" type="datetimeFigureOut">
               <a:rPr lang="en-US" smtClean="0"/>
-              <a:t>4/7/2026</a:t>
+              <a:t>4/8/2026</a:t>
             </a:fld>
             <a:endParaRPr lang="en-US"/>
           </a:p>
@@ -8659,6 +8666,2312 @@
     <p:extLst>
       <p:ext uri="{BB962C8B-B14F-4D97-AF65-F5344CB8AC3E}">
         <p14:creationId xmlns:p14="http://schemas.microsoft.com/office/powerpoint/2010/main" val="2913696814"/>
+      </p:ext>
+    </p:extLst>
+  </p:cSld>
+  <p:clrMapOvr>
+    <a:masterClrMapping/>
+  </p:clrMapOvr>
+</p:sld>
+</file>
+
+<file path=ppt/slides/slide3.xml><?xml version="1.0" encoding="utf-8"?>
+<p:sld xmlns:a="http://schemas.openxmlformats.org/drawingml/2006/main" xmlns:r="http://schemas.openxmlformats.org/officeDocument/2006/relationships" xmlns:p="http://schemas.openxmlformats.org/presentationml/2006/main">
+  <p:cSld>
+    <p:spTree>
+      <p:nvGrpSpPr>
+        <p:cNvPr id="1" name=""/>
+        <p:cNvGrpSpPr/>
+        <p:nvPr/>
+      </p:nvGrpSpPr>
+      <p:grpSpPr>
+        <a:xfrm>
+          <a:off x="0" y="0"/>
+          <a:ext cx="0" cy="0"/>
+          <a:chOff x="0" y="0"/>
+          <a:chExt cx="0" cy="0"/>
+        </a:xfrm>
+      </p:grpSpPr>
+      <p:sp>
+        <p:nvSpPr>
+          <p:cNvPr id="69" name="Rectangle: Rounded Corners 68">
+            <a:extLst>
+              <a:ext uri="{FF2B5EF4-FFF2-40B4-BE49-F238E27FC236}">
+                <a16:creationId xmlns:a16="http://schemas.microsoft.com/office/drawing/2014/main" id="{060D4AF3-3C02-05DA-D79E-8AE11E677776}"/>
+              </a:ext>
+            </a:extLst>
+          </p:cNvPr>
+          <p:cNvSpPr/>
+          <p:nvPr/>
+        </p:nvSpPr>
+        <p:spPr>
+          <a:xfrm>
+            <a:off x="192230" y="91440"/>
+            <a:ext cx="8692690" cy="6531788"/>
+          </a:xfrm>
+          <a:prstGeom prst="roundRect">
+            <a:avLst>
+              <a:gd name="adj" fmla="val 5351"/>
+            </a:avLst>
+          </a:prstGeom>
+          <a:noFill/>
+          <a:ln>
+            <a:solidFill>
+              <a:schemeClr val="accent1">
+                <a:lumMod val="75000"/>
+              </a:schemeClr>
+            </a:solidFill>
+          </a:ln>
+        </p:spPr>
+        <p:style>
+          <a:lnRef idx="2">
+            <a:schemeClr val="accent1">
+              <a:shade val="15000"/>
+            </a:schemeClr>
+          </a:lnRef>
+          <a:fillRef idx="1">
+            <a:schemeClr val="accent1"/>
+          </a:fillRef>
+          <a:effectRef idx="0">
+            <a:schemeClr val="accent1"/>
+          </a:effectRef>
+          <a:fontRef idx="minor">
+            <a:schemeClr val="lt1"/>
+          </a:fontRef>
+        </p:style>
+        <p:txBody>
+          <a:bodyPr rtlCol="0" anchor="ctr"/>
+          <a:lstStyle/>
+          <a:p>
+            <a:pPr algn="ctr"/>
+            <a:endParaRPr lang="en-US"/>
+          </a:p>
+        </p:txBody>
+      </p:sp>
+      <p:sp>
+        <p:nvSpPr>
+          <p:cNvPr id="8" name="TextBox 7">
+            <a:extLst>
+              <a:ext uri="{FF2B5EF4-FFF2-40B4-BE49-F238E27FC236}">
+                <a16:creationId xmlns:a16="http://schemas.microsoft.com/office/drawing/2014/main" id="{079F9AF0-9829-F5B1-AF9F-D5B719477D0D}"/>
+              </a:ext>
+            </a:extLst>
+          </p:cNvPr>
+          <p:cNvSpPr txBox="1"/>
+          <p:nvPr/>
+        </p:nvSpPr>
+        <p:spPr>
+          <a:xfrm>
+            <a:off x="265673" y="410268"/>
+            <a:ext cx="1271002" cy="369332"/>
+          </a:xfrm>
+          <a:prstGeom prst="rect">
+            <a:avLst/>
+          </a:prstGeom>
+          <a:noFill/>
+        </p:spPr>
+        <p:txBody>
+          <a:bodyPr wrap="square" rtlCol="0">
+            <a:spAutoFit/>
+          </a:bodyPr>
+          <a:lstStyle/>
+          <a:p>
+            <a:pPr algn="ctr"/>
+            <a:r>
+              <a:rPr lang="en-US" dirty="0"/>
+              <a:t>Set up</a:t>
+            </a:r>
+          </a:p>
+        </p:txBody>
+      </p:sp>
+      <p:sp>
+        <p:nvSpPr>
+          <p:cNvPr id="9" name="TextBox 8">
+            <a:extLst>
+              <a:ext uri="{FF2B5EF4-FFF2-40B4-BE49-F238E27FC236}">
+                <a16:creationId xmlns:a16="http://schemas.microsoft.com/office/drawing/2014/main" id="{2F7A4BD4-EE9D-ADD6-30D9-369588BB68A5}"/>
+              </a:ext>
+            </a:extLst>
+          </p:cNvPr>
+          <p:cNvSpPr txBox="1"/>
+          <p:nvPr/>
+        </p:nvSpPr>
+        <p:spPr>
+          <a:xfrm>
+            <a:off x="192230" y="1170833"/>
+            <a:ext cx="1417888" cy="369332"/>
+          </a:xfrm>
+          <a:prstGeom prst="rect">
+            <a:avLst/>
+          </a:prstGeom>
+          <a:noFill/>
+        </p:spPr>
+        <p:txBody>
+          <a:bodyPr wrap="square" rtlCol="0">
+            <a:spAutoFit/>
+          </a:bodyPr>
+          <a:lstStyle/>
+          <a:p>
+            <a:pPr algn="ctr"/>
+            <a:r>
+              <a:rPr lang="en-US" dirty="0"/>
+              <a:t>Per sample</a:t>
+            </a:r>
+          </a:p>
+        </p:txBody>
+      </p:sp>
+      <p:sp>
+        <p:nvSpPr>
+          <p:cNvPr id="10" name="TextBox 9">
+            <a:extLst>
+              <a:ext uri="{FF2B5EF4-FFF2-40B4-BE49-F238E27FC236}">
+                <a16:creationId xmlns:a16="http://schemas.microsoft.com/office/drawing/2014/main" id="{948A5637-D222-49AA-2431-474A59C96841}"/>
+              </a:ext>
+            </a:extLst>
+          </p:cNvPr>
+          <p:cNvSpPr txBox="1"/>
+          <p:nvPr/>
+        </p:nvSpPr>
+        <p:spPr>
+          <a:xfrm>
+            <a:off x="265673" y="2306397"/>
+            <a:ext cx="1271002" cy="369332"/>
+          </a:xfrm>
+          <a:prstGeom prst="rect">
+            <a:avLst/>
+          </a:prstGeom>
+          <a:noFill/>
+        </p:spPr>
+        <p:txBody>
+          <a:bodyPr wrap="square" rtlCol="0">
+            <a:spAutoFit/>
+          </a:bodyPr>
+          <a:lstStyle/>
+          <a:p>
+            <a:pPr algn="ctr"/>
+            <a:r>
+              <a:rPr lang="en-US" dirty="0"/>
+              <a:t>Prefill</a:t>
+            </a:r>
+          </a:p>
+        </p:txBody>
+      </p:sp>
+      <p:sp>
+        <p:nvSpPr>
+          <p:cNvPr id="11" name="TextBox 10">
+            <a:extLst>
+              <a:ext uri="{FF2B5EF4-FFF2-40B4-BE49-F238E27FC236}">
+                <a16:creationId xmlns:a16="http://schemas.microsoft.com/office/drawing/2014/main" id="{982B9F00-00E2-6A56-4EC8-92313CA28DE2}"/>
+              </a:ext>
+            </a:extLst>
+          </p:cNvPr>
+          <p:cNvSpPr txBox="1"/>
+          <p:nvPr/>
+        </p:nvSpPr>
+        <p:spPr>
+          <a:xfrm>
+            <a:off x="39126" y="4519846"/>
+            <a:ext cx="1897982" cy="369332"/>
+          </a:xfrm>
+          <a:prstGeom prst="rect">
+            <a:avLst/>
+          </a:prstGeom>
+          <a:noFill/>
+        </p:spPr>
+        <p:txBody>
+          <a:bodyPr wrap="square" rtlCol="0">
+            <a:spAutoFit/>
+          </a:bodyPr>
+          <a:lstStyle/>
+          <a:p>
+            <a:pPr algn="ctr"/>
+            <a:r>
+              <a:rPr lang="en-US" dirty="0"/>
+              <a:t>Decode step</a:t>
+            </a:r>
+          </a:p>
+        </p:txBody>
+      </p:sp>
+      <p:sp>
+        <p:nvSpPr>
+          <p:cNvPr id="12" name="Rectangle: Rounded Corners 11">
+            <a:extLst>
+              <a:ext uri="{FF2B5EF4-FFF2-40B4-BE49-F238E27FC236}">
+                <a16:creationId xmlns:a16="http://schemas.microsoft.com/office/drawing/2014/main" id="{8C0337FE-FE0B-2C6B-A3A1-B73F35E247FD}"/>
+              </a:ext>
+            </a:extLst>
+          </p:cNvPr>
+          <p:cNvSpPr/>
+          <p:nvPr/>
+        </p:nvSpPr>
+        <p:spPr>
+          <a:xfrm>
+            <a:off x="2046280" y="234193"/>
+            <a:ext cx="2297907" cy="604586"/>
+          </a:xfrm>
+          <a:prstGeom prst="roundRect">
+            <a:avLst/>
+          </a:prstGeom>
+          <a:solidFill>
+            <a:schemeClr val="accent2">
+              <a:lumMod val="20000"/>
+              <a:lumOff val="80000"/>
+            </a:schemeClr>
+          </a:solidFill>
+          <a:ln>
+            <a:solidFill>
+              <a:schemeClr val="accent2">
+                <a:lumMod val="75000"/>
+              </a:schemeClr>
+            </a:solidFill>
+          </a:ln>
+        </p:spPr>
+        <p:style>
+          <a:lnRef idx="2">
+            <a:schemeClr val="accent1">
+              <a:shade val="15000"/>
+            </a:schemeClr>
+          </a:lnRef>
+          <a:fillRef idx="1">
+            <a:schemeClr val="accent1"/>
+          </a:fillRef>
+          <a:effectRef idx="0">
+            <a:schemeClr val="accent1"/>
+          </a:effectRef>
+          <a:fontRef idx="minor">
+            <a:schemeClr val="lt1"/>
+          </a:fontRef>
+        </p:style>
+        <p:txBody>
+          <a:bodyPr rtlCol="0" anchor="ctr"/>
+          <a:lstStyle/>
+          <a:p>
+            <a:pPr algn="ctr"/>
+            <a:r>
+              <a:rPr lang="en-US" sz="1200" b="1" dirty="0">
+                <a:solidFill>
+                  <a:schemeClr val="tx1">
+                    <a:lumMod val="95000"/>
+                    <a:lumOff val="5000"/>
+                  </a:schemeClr>
+                </a:solidFill>
+                <a:latin typeface="Times New Roman" panose="02020603050405020304" pitchFamily="18" charset="0"/>
+                <a:cs typeface="Times New Roman" panose="02020603050405020304" pitchFamily="18" charset="0"/>
+              </a:rPr>
+              <a:t>Patch </a:t>
+            </a:r>
+            <a:r>
+              <a:rPr lang="en-US" sz="1200" b="1" dirty="0" err="1">
+                <a:solidFill>
+                  <a:schemeClr val="tx1">
+                    <a:lumMod val="95000"/>
+                    <a:lumOff val="5000"/>
+                  </a:schemeClr>
+                </a:solidFill>
+                <a:latin typeface="Times New Roman" panose="02020603050405020304" pitchFamily="18" charset="0"/>
+                <a:cs typeface="Times New Roman" panose="02020603050405020304" pitchFamily="18" charset="0"/>
+              </a:rPr>
+              <a:t>attn.forward</a:t>
+            </a:r>
+            <a:endParaRPr lang="en-US" sz="1200" b="1" dirty="0">
+              <a:solidFill>
+                <a:schemeClr val="tx1">
+                  <a:lumMod val="95000"/>
+                  <a:lumOff val="5000"/>
+                </a:schemeClr>
+              </a:solidFill>
+              <a:latin typeface="Times New Roman" panose="02020603050405020304" pitchFamily="18" charset="0"/>
+              <a:cs typeface="Times New Roman" panose="02020603050405020304" pitchFamily="18" charset="0"/>
+            </a:endParaRPr>
+          </a:p>
+          <a:p>
+            <a:pPr algn="ctr"/>
+            <a:r>
+              <a:rPr lang="en-US" sz="1200" dirty="0">
+                <a:solidFill>
+                  <a:schemeClr val="tx1"/>
+                </a:solidFill>
+                <a:latin typeface="Times New Roman" panose="02020603050405020304" pitchFamily="18" charset="0"/>
+                <a:cs typeface="Times New Roman" panose="02020603050405020304" pitchFamily="18" charset="0"/>
+              </a:rPr>
+              <a:t>All 16 layers</a:t>
+            </a:r>
+          </a:p>
+          <a:p>
+            <a:pPr algn="ctr"/>
+            <a:r>
+              <a:rPr lang="en-US" sz="1200" dirty="0">
+                <a:solidFill>
+                  <a:schemeClr val="tx1"/>
+                </a:solidFill>
+                <a:latin typeface="Times New Roman" panose="02020603050405020304" pitchFamily="18" charset="0"/>
+                <a:cs typeface="Times New Roman" panose="02020603050405020304" pitchFamily="18" charset="0"/>
+              </a:rPr>
+              <a:t>Set </a:t>
+            </a:r>
+            <a:r>
+              <a:rPr lang="en-US" sz="1200" dirty="0" err="1">
+                <a:solidFill>
+                  <a:schemeClr val="tx1"/>
+                </a:solidFill>
+                <a:latin typeface="Times New Roman" panose="02020603050405020304" pitchFamily="18" charset="0"/>
+                <a:cs typeface="Times New Roman" panose="02020603050405020304" pitchFamily="18" charset="0"/>
+              </a:rPr>
+              <a:t>output_attenttions</a:t>
+            </a:r>
+            <a:r>
+              <a:rPr lang="en-US" sz="1200" dirty="0">
+                <a:solidFill>
+                  <a:schemeClr val="tx1"/>
+                </a:solidFill>
+                <a:latin typeface="Times New Roman" panose="02020603050405020304" pitchFamily="18" charset="0"/>
+                <a:cs typeface="Times New Roman" panose="02020603050405020304" pitchFamily="18" charset="0"/>
+              </a:rPr>
+              <a:t>=True </a:t>
+            </a:r>
+          </a:p>
+        </p:txBody>
+      </p:sp>
+      <p:sp>
+        <p:nvSpPr>
+          <p:cNvPr id="13" name="Rectangle: Rounded Corners 12">
+            <a:extLst>
+              <a:ext uri="{FF2B5EF4-FFF2-40B4-BE49-F238E27FC236}">
+                <a16:creationId xmlns:a16="http://schemas.microsoft.com/office/drawing/2014/main" id="{0E31B3E6-C7EA-FB3E-D809-CCFC9845BCF1}"/>
+              </a:ext>
+            </a:extLst>
+          </p:cNvPr>
+          <p:cNvSpPr/>
+          <p:nvPr/>
+        </p:nvSpPr>
+        <p:spPr>
+          <a:xfrm>
+            <a:off x="4958935" y="234772"/>
+            <a:ext cx="3173417" cy="604586"/>
+          </a:xfrm>
+          <a:prstGeom prst="roundRect">
+            <a:avLst/>
+          </a:prstGeom>
+          <a:solidFill>
+            <a:schemeClr val="accent2">
+              <a:lumMod val="20000"/>
+              <a:lumOff val="80000"/>
+            </a:schemeClr>
+          </a:solidFill>
+          <a:ln>
+            <a:solidFill>
+              <a:schemeClr val="accent2">
+                <a:lumMod val="75000"/>
+              </a:schemeClr>
+            </a:solidFill>
+          </a:ln>
+        </p:spPr>
+        <p:style>
+          <a:lnRef idx="2">
+            <a:schemeClr val="accent1">
+              <a:shade val="15000"/>
+            </a:schemeClr>
+          </a:lnRef>
+          <a:fillRef idx="1">
+            <a:schemeClr val="accent1"/>
+          </a:fillRef>
+          <a:effectRef idx="0">
+            <a:schemeClr val="accent1"/>
+          </a:effectRef>
+          <a:fontRef idx="minor">
+            <a:schemeClr val="lt1"/>
+          </a:fontRef>
+        </p:style>
+        <p:txBody>
+          <a:bodyPr rtlCol="0" anchor="ctr"/>
+          <a:lstStyle/>
+          <a:p>
+            <a:pPr algn="ctr"/>
+            <a:r>
+              <a:rPr lang="en-US" sz="1200" b="1" dirty="0">
+                <a:solidFill>
+                  <a:schemeClr val="tx1">
+                    <a:lumMod val="95000"/>
+                    <a:lumOff val="5000"/>
+                  </a:schemeClr>
+                </a:solidFill>
+                <a:latin typeface="Times New Roman" panose="02020603050405020304" pitchFamily="18" charset="0"/>
+                <a:cs typeface="Times New Roman" panose="02020603050405020304" pitchFamily="18" charset="0"/>
+              </a:rPr>
+              <a:t>Register eviction hook</a:t>
+            </a:r>
+          </a:p>
+          <a:p>
+            <a:pPr algn="ctr"/>
+            <a:r>
+              <a:rPr lang="en-US" sz="1200" dirty="0" err="1">
+                <a:solidFill>
+                  <a:schemeClr val="tx1"/>
+                </a:solidFill>
+                <a:latin typeface="Times New Roman" panose="02020603050405020304" pitchFamily="18" charset="0"/>
+                <a:cs typeface="Times New Roman" panose="02020603050405020304" pitchFamily="18" charset="0"/>
+              </a:rPr>
+              <a:t>modle.model.rehoster_forward_hook</a:t>
+            </a:r>
+            <a:endParaRPr lang="en-US" sz="1200" dirty="0">
+              <a:solidFill>
+                <a:schemeClr val="tx1"/>
+              </a:solidFill>
+              <a:latin typeface="Times New Roman" panose="02020603050405020304" pitchFamily="18" charset="0"/>
+              <a:cs typeface="Times New Roman" panose="02020603050405020304" pitchFamily="18" charset="0"/>
+            </a:endParaRPr>
+          </a:p>
+        </p:txBody>
+      </p:sp>
+      <p:sp>
+        <p:nvSpPr>
+          <p:cNvPr id="14" name="Rectangle: Rounded Corners 13">
+            <a:extLst>
+              <a:ext uri="{FF2B5EF4-FFF2-40B4-BE49-F238E27FC236}">
+                <a16:creationId xmlns:a16="http://schemas.microsoft.com/office/drawing/2014/main" id="{8B3A280E-1994-F804-E2F8-B933132057F6}"/>
+              </a:ext>
+            </a:extLst>
+          </p:cNvPr>
+          <p:cNvSpPr/>
+          <p:nvPr/>
+        </p:nvSpPr>
+        <p:spPr>
+          <a:xfrm>
+            <a:off x="2046280" y="1200183"/>
+            <a:ext cx="2297907" cy="310633"/>
+          </a:xfrm>
+          <a:prstGeom prst="roundRect">
+            <a:avLst/>
+          </a:prstGeom>
+          <a:solidFill>
+            <a:schemeClr val="bg2"/>
+          </a:solidFill>
+          <a:ln>
+            <a:solidFill>
+              <a:schemeClr val="bg1">
+                <a:lumMod val="75000"/>
+              </a:schemeClr>
+            </a:solidFill>
+          </a:ln>
+        </p:spPr>
+        <p:style>
+          <a:lnRef idx="2">
+            <a:schemeClr val="accent1">
+              <a:shade val="15000"/>
+            </a:schemeClr>
+          </a:lnRef>
+          <a:fillRef idx="1">
+            <a:schemeClr val="accent1"/>
+          </a:fillRef>
+          <a:effectRef idx="0">
+            <a:schemeClr val="accent1"/>
+          </a:effectRef>
+          <a:fontRef idx="minor">
+            <a:schemeClr val="lt1"/>
+          </a:fontRef>
+        </p:style>
+        <p:txBody>
+          <a:bodyPr rtlCol="0" anchor="ctr"/>
+          <a:lstStyle/>
+          <a:p>
+            <a:pPr algn="ctr"/>
+            <a:r>
+              <a:rPr lang="en-US" sz="1200" b="1" dirty="0">
+                <a:solidFill>
+                  <a:schemeClr val="tx1">
+                    <a:lumMod val="95000"/>
+                    <a:lumOff val="5000"/>
+                  </a:schemeClr>
+                </a:solidFill>
+                <a:latin typeface="Times New Roman" panose="02020603050405020304" pitchFamily="18" charset="0"/>
+                <a:cs typeface="Times New Roman" panose="02020603050405020304" pitchFamily="18" charset="0"/>
+              </a:rPr>
+              <a:t>Reset scores() for heavy hitters</a:t>
+            </a:r>
+            <a:endParaRPr lang="en-US" sz="1200" dirty="0">
+              <a:solidFill>
+                <a:schemeClr val="tx1"/>
+              </a:solidFill>
+              <a:latin typeface="Times New Roman" panose="02020603050405020304" pitchFamily="18" charset="0"/>
+              <a:cs typeface="Times New Roman" panose="02020603050405020304" pitchFamily="18" charset="0"/>
+            </a:endParaRPr>
+          </a:p>
+        </p:txBody>
+      </p:sp>
+      <p:sp>
+        <p:nvSpPr>
+          <p:cNvPr id="15" name="Rectangle: Rounded Corners 14">
+            <a:extLst>
+              <a:ext uri="{FF2B5EF4-FFF2-40B4-BE49-F238E27FC236}">
+                <a16:creationId xmlns:a16="http://schemas.microsoft.com/office/drawing/2014/main" id="{34DE8E1F-14E3-37C7-4984-18A48325A598}"/>
+              </a:ext>
+            </a:extLst>
+          </p:cNvPr>
+          <p:cNvSpPr/>
+          <p:nvPr/>
+        </p:nvSpPr>
+        <p:spPr>
+          <a:xfrm>
+            <a:off x="4973555" y="1202174"/>
+            <a:ext cx="3173417" cy="310633"/>
+          </a:xfrm>
+          <a:prstGeom prst="roundRect">
+            <a:avLst/>
+          </a:prstGeom>
+          <a:solidFill>
+            <a:schemeClr val="bg2"/>
+          </a:solidFill>
+          <a:ln>
+            <a:solidFill>
+              <a:schemeClr val="bg1">
+                <a:lumMod val="75000"/>
+              </a:schemeClr>
+            </a:solidFill>
+          </a:ln>
+        </p:spPr>
+        <p:style>
+          <a:lnRef idx="2">
+            <a:schemeClr val="accent1">
+              <a:shade val="15000"/>
+            </a:schemeClr>
+          </a:lnRef>
+          <a:fillRef idx="1">
+            <a:schemeClr val="accent1"/>
+          </a:fillRef>
+          <a:effectRef idx="0">
+            <a:schemeClr val="accent1"/>
+          </a:effectRef>
+          <a:fontRef idx="minor">
+            <a:schemeClr val="lt1"/>
+          </a:fontRef>
+        </p:style>
+        <p:txBody>
+          <a:bodyPr rtlCol="0" anchor="ctr"/>
+          <a:lstStyle/>
+          <a:p>
+            <a:pPr algn="ctr"/>
+            <a:r>
+              <a:rPr lang="en-US" sz="1200" b="1" dirty="0" err="1">
+                <a:solidFill>
+                  <a:schemeClr val="tx1">
+                    <a:lumMod val="95000"/>
+                    <a:lumOff val="5000"/>
+                  </a:schemeClr>
+                </a:solidFill>
+                <a:latin typeface="Times New Roman" panose="02020603050405020304" pitchFamily="18" charset="0"/>
+                <a:cs typeface="Times New Roman" panose="02020603050405020304" pitchFamily="18" charset="0"/>
+              </a:rPr>
+              <a:t>model.generate</a:t>
+            </a:r>
+            <a:r>
+              <a:rPr lang="en-US" sz="1200" b="1" dirty="0">
+                <a:solidFill>
+                  <a:schemeClr val="tx1">
+                    <a:lumMod val="95000"/>
+                    <a:lumOff val="5000"/>
+                  </a:schemeClr>
+                </a:solidFill>
+                <a:latin typeface="Times New Roman" panose="02020603050405020304" pitchFamily="18" charset="0"/>
+                <a:cs typeface="Times New Roman" panose="02020603050405020304" pitchFamily="18" charset="0"/>
+              </a:rPr>
+              <a:t>() with prompts and article</a:t>
+            </a:r>
+            <a:endParaRPr lang="en-US" sz="1200" dirty="0">
+              <a:solidFill>
+                <a:schemeClr val="tx1"/>
+              </a:solidFill>
+              <a:latin typeface="Times New Roman" panose="02020603050405020304" pitchFamily="18" charset="0"/>
+              <a:cs typeface="Times New Roman" panose="02020603050405020304" pitchFamily="18" charset="0"/>
+            </a:endParaRPr>
+          </a:p>
+        </p:txBody>
+      </p:sp>
+      <p:sp>
+        <p:nvSpPr>
+          <p:cNvPr id="16" name="Rectangle: Rounded Corners 15">
+            <a:extLst>
+              <a:ext uri="{FF2B5EF4-FFF2-40B4-BE49-F238E27FC236}">
+                <a16:creationId xmlns:a16="http://schemas.microsoft.com/office/drawing/2014/main" id="{31DD7100-8E66-72AA-4140-69062094222D}"/>
+              </a:ext>
+            </a:extLst>
+          </p:cNvPr>
+          <p:cNvSpPr/>
+          <p:nvPr/>
+        </p:nvSpPr>
+        <p:spPr>
+          <a:xfrm>
+            <a:off x="2046280" y="2201658"/>
+            <a:ext cx="2297906" cy="533366"/>
+          </a:xfrm>
+          <a:prstGeom prst="roundRect">
+            <a:avLst/>
+          </a:prstGeom>
+          <a:solidFill>
+            <a:schemeClr val="accent1">
+              <a:lumMod val="20000"/>
+              <a:lumOff val="80000"/>
+            </a:schemeClr>
+          </a:solidFill>
+          <a:ln>
+            <a:solidFill>
+              <a:schemeClr val="tx2">
+                <a:lumMod val="90000"/>
+                <a:lumOff val="10000"/>
+              </a:schemeClr>
+            </a:solidFill>
+          </a:ln>
+        </p:spPr>
+        <p:style>
+          <a:lnRef idx="2">
+            <a:schemeClr val="accent1">
+              <a:shade val="15000"/>
+            </a:schemeClr>
+          </a:lnRef>
+          <a:fillRef idx="1">
+            <a:schemeClr val="accent1"/>
+          </a:fillRef>
+          <a:effectRef idx="0">
+            <a:schemeClr val="accent1"/>
+          </a:effectRef>
+          <a:fontRef idx="minor">
+            <a:schemeClr val="lt1"/>
+          </a:fontRef>
+        </p:style>
+        <p:txBody>
+          <a:bodyPr wrap="none" rtlCol="0" anchor="t" anchorCtr="0"/>
+          <a:lstStyle/>
+          <a:p>
+            <a:pPr algn="ctr"/>
+            <a:r>
+              <a:rPr lang="en-US" sz="1200" b="1" dirty="0">
+                <a:solidFill>
+                  <a:schemeClr val="tx1">
+                    <a:lumMod val="95000"/>
+                    <a:lumOff val="5000"/>
+                  </a:schemeClr>
+                </a:solidFill>
+                <a:latin typeface="Times New Roman" panose="02020603050405020304" pitchFamily="18" charset="0"/>
+                <a:cs typeface="Times New Roman" panose="02020603050405020304" pitchFamily="18" charset="0"/>
+              </a:rPr>
+              <a:t>P</a:t>
+            </a:r>
+            <a:r>
+              <a:rPr lang="en-US" altLang="zh-CN" sz="1200" b="1" dirty="0">
+                <a:solidFill>
+                  <a:schemeClr val="tx1">
+                    <a:lumMod val="95000"/>
+                    <a:lumOff val="5000"/>
+                  </a:schemeClr>
+                </a:solidFill>
+                <a:latin typeface="Times New Roman" panose="02020603050405020304" pitchFamily="18" charset="0"/>
+                <a:cs typeface="Times New Roman" panose="02020603050405020304" pitchFamily="18" charset="0"/>
+              </a:rPr>
+              <a:t>refill with full sequence </a:t>
+            </a:r>
+          </a:p>
+          <a:p>
+            <a:pPr algn="ctr"/>
+            <a:r>
+              <a:rPr lang="en-US" altLang="zh-CN" sz="1200" b="1" dirty="0">
+                <a:solidFill>
+                  <a:schemeClr val="tx1">
+                    <a:lumMod val="95000"/>
+                    <a:lumOff val="5000"/>
+                  </a:schemeClr>
+                </a:solidFill>
+                <a:latin typeface="Times New Roman" panose="02020603050405020304" pitchFamily="18" charset="0"/>
+                <a:cs typeface="Times New Roman" panose="02020603050405020304" pitchFamily="18" charset="0"/>
+              </a:rPr>
+              <a:t>prompt to fill KV cache</a:t>
+            </a:r>
+            <a:endParaRPr lang="en-US" sz="1200" dirty="0">
+              <a:solidFill>
+                <a:schemeClr val="tx1"/>
+              </a:solidFill>
+              <a:latin typeface="Times New Roman" panose="02020603050405020304" pitchFamily="18" charset="0"/>
+              <a:cs typeface="Times New Roman" panose="02020603050405020304" pitchFamily="18" charset="0"/>
+            </a:endParaRPr>
+          </a:p>
+        </p:txBody>
+      </p:sp>
+      <p:sp>
+        <p:nvSpPr>
+          <p:cNvPr id="18" name="Rectangle: Rounded Corners 17">
+            <a:extLst>
+              <a:ext uri="{FF2B5EF4-FFF2-40B4-BE49-F238E27FC236}">
+                <a16:creationId xmlns:a16="http://schemas.microsoft.com/office/drawing/2014/main" id="{970D77B6-6AD8-98CA-5673-D89DCBC1772F}"/>
+              </a:ext>
+            </a:extLst>
+          </p:cNvPr>
+          <p:cNvSpPr/>
+          <p:nvPr/>
+        </p:nvSpPr>
+        <p:spPr>
+          <a:xfrm>
+            <a:off x="4973556" y="2140447"/>
+            <a:ext cx="3173415" cy="701232"/>
+          </a:xfrm>
+          <a:prstGeom prst="roundRect">
+            <a:avLst/>
+          </a:prstGeom>
+          <a:solidFill>
+            <a:schemeClr val="accent1">
+              <a:lumMod val="20000"/>
+              <a:lumOff val="80000"/>
+            </a:schemeClr>
+          </a:solidFill>
+          <a:ln>
+            <a:solidFill>
+              <a:schemeClr val="tx2">
+                <a:lumMod val="90000"/>
+                <a:lumOff val="10000"/>
+              </a:schemeClr>
+            </a:solidFill>
+          </a:ln>
+        </p:spPr>
+        <p:style>
+          <a:lnRef idx="2">
+            <a:schemeClr val="accent1">
+              <a:shade val="15000"/>
+            </a:schemeClr>
+          </a:lnRef>
+          <a:fillRef idx="1">
+            <a:schemeClr val="accent1"/>
+          </a:fillRef>
+          <a:effectRef idx="0">
+            <a:schemeClr val="accent1"/>
+          </a:effectRef>
+          <a:fontRef idx="minor">
+            <a:schemeClr val="lt1"/>
+          </a:fontRef>
+        </p:style>
+        <p:txBody>
+          <a:bodyPr wrap="none" rtlCol="0" anchor="t" anchorCtr="0"/>
+          <a:lstStyle/>
+          <a:p>
+            <a:pPr algn="ctr"/>
+            <a:r>
+              <a:rPr lang="en-US" sz="1200" b="1" dirty="0">
+                <a:solidFill>
+                  <a:schemeClr val="tx1">
+                    <a:lumMod val="95000"/>
+                    <a:lumOff val="5000"/>
+                  </a:schemeClr>
+                </a:solidFill>
+                <a:latin typeface="Times New Roman" panose="02020603050405020304" pitchFamily="18" charset="0"/>
+                <a:cs typeface="Times New Roman" panose="02020603050405020304" pitchFamily="18" charset="0"/>
+              </a:rPr>
+              <a:t>Eviction hook select:</a:t>
+            </a:r>
+          </a:p>
+          <a:p>
+            <a:pPr marL="171450" indent="-171450">
+              <a:buFont typeface="Arial" panose="020B0604020202020204" pitchFamily="34" charset="0"/>
+              <a:buChar char="•"/>
+            </a:pPr>
+            <a:r>
+              <a:rPr lang="en-US" sz="1200" b="1" dirty="0">
+                <a:solidFill>
+                  <a:schemeClr val="tx1">
+                    <a:lumMod val="95000"/>
+                    <a:lumOff val="5000"/>
+                  </a:schemeClr>
+                </a:solidFill>
+                <a:latin typeface="Times New Roman" panose="02020603050405020304" pitchFamily="18" charset="0"/>
+                <a:cs typeface="Times New Roman" panose="02020603050405020304" pitchFamily="18" charset="0"/>
+              </a:rPr>
+              <a:t>heavy hitters with accumulated scores </a:t>
+            </a:r>
+          </a:p>
+          <a:p>
+            <a:pPr marL="171450" indent="-171450">
+              <a:buFont typeface="Arial" panose="020B0604020202020204" pitchFamily="34" charset="0"/>
+              <a:buChar char="•"/>
+            </a:pPr>
+            <a:r>
+              <a:rPr lang="en-US" sz="1200" b="1" dirty="0">
+                <a:solidFill>
+                  <a:schemeClr val="tx1">
+                    <a:lumMod val="95000"/>
+                    <a:lumOff val="5000"/>
+                  </a:schemeClr>
+                </a:solidFill>
+                <a:latin typeface="Times New Roman" panose="02020603050405020304" pitchFamily="18" charset="0"/>
+                <a:cs typeface="Times New Roman" panose="02020603050405020304" pitchFamily="18" charset="0"/>
+              </a:rPr>
+              <a:t>recent window</a:t>
+            </a:r>
+          </a:p>
+        </p:txBody>
+      </p:sp>
+      <p:sp>
+        <p:nvSpPr>
+          <p:cNvPr id="19" name="Rectangle: Rounded Corners 18">
+            <a:extLst>
+              <a:ext uri="{FF2B5EF4-FFF2-40B4-BE49-F238E27FC236}">
+                <a16:creationId xmlns:a16="http://schemas.microsoft.com/office/drawing/2014/main" id="{FEFBFC88-1615-49B0-73C7-52499E70CA06}"/>
+              </a:ext>
+            </a:extLst>
+          </p:cNvPr>
+          <p:cNvSpPr/>
+          <p:nvPr/>
+        </p:nvSpPr>
+        <p:spPr>
+          <a:xfrm>
+            <a:off x="2630277" y="3385863"/>
+            <a:ext cx="4270700" cy="573504"/>
+          </a:xfrm>
+          <a:prstGeom prst="roundRect">
+            <a:avLst/>
+          </a:prstGeom>
+          <a:solidFill>
+            <a:srgbClr val="FFC000"/>
+          </a:solidFill>
+          <a:ln>
+            <a:solidFill>
+              <a:schemeClr val="bg1">
+                <a:lumMod val="50000"/>
+              </a:schemeClr>
+            </a:solidFill>
+          </a:ln>
+        </p:spPr>
+        <p:style>
+          <a:lnRef idx="2">
+            <a:schemeClr val="accent1">
+              <a:shade val="15000"/>
+            </a:schemeClr>
+          </a:lnRef>
+          <a:fillRef idx="1">
+            <a:schemeClr val="accent1"/>
+          </a:fillRef>
+          <a:effectRef idx="0">
+            <a:schemeClr val="accent1"/>
+          </a:effectRef>
+          <a:fontRef idx="minor">
+            <a:schemeClr val="lt1"/>
+          </a:fontRef>
+        </p:style>
+        <p:txBody>
+          <a:bodyPr wrap="none" rtlCol="0" anchor="t" anchorCtr="0"/>
+          <a:lstStyle/>
+          <a:p>
+            <a:pPr algn="ctr"/>
+            <a:r>
+              <a:rPr lang="en-US" altLang="zh-CN" sz="1200" dirty="0">
+                <a:solidFill>
+                  <a:schemeClr val="tx1"/>
+                </a:solidFill>
+                <a:latin typeface="Times New Roman" panose="02020603050405020304" pitchFamily="18" charset="0"/>
+                <a:cs typeface="Times New Roman" panose="02020603050405020304" pitchFamily="18" charset="0"/>
+              </a:rPr>
+              <a:t>Patched forward</a:t>
+            </a:r>
+          </a:p>
+          <a:p>
+            <a:pPr algn="ctr"/>
+            <a:r>
+              <a:rPr lang="en-US" sz="1200" dirty="0">
+                <a:solidFill>
+                  <a:schemeClr val="tx1"/>
+                </a:solidFill>
+                <a:latin typeface="Times New Roman" panose="02020603050405020304" pitchFamily="18" charset="0"/>
+                <a:cs typeface="Times New Roman" panose="02020603050405020304" pitchFamily="18" charset="0"/>
+              </a:rPr>
+              <a:t>New token comes-&gt; update accumulated score</a:t>
+            </a:r>
+          </a:p>
+        </p:txBody>
+      </p:sp>
+      <p:sp>
+        <p:nvSpPr>
+          <p:cNvPr id="20" name="Rectangle: Rounded Corners 19">
+            <a:extLst>
+              <a:ext uri="{FF2B5EF4-FFF2-40B4-BE49-F238E27FC236}">
+                <a16:creationId xmlns:a16="http://schemas.microsoft.com/office/drawing/2014/main" id="{5FEF8097-B215-7221-530C-E15FD88528FF}"/>
+              </a:ext>
+            </a:extLst>
+          </p:cNvPr>
+          <p:cNvSpPr/>
+          <p:nvPr/>
+        </p:nvSpPr>
+        <p:spPr>
+          <a:xfrm>
+            <a:off x="2630277" y="5282108"/>
+            <a:ext cx="1642557" cy="310633"/>
+          </a:xfrm>
+          <a:prstGeom prst="roundRect">
+            <a:avLst/>
+          </a:prstGeom>
+          <a:solidFill>
+            <a:srgbClr val="FFC000"/>
+          </a:solidFill>
+          <a:ln>
+            <a:solidFill>
+              <a:schemeClr val="bg1">
+                <a:lumMod val="50000"/>
+              </a:schemeClr>
+            </a:solidFill>
+          </a:ln>
+        </p:spPr>
+        <p:style>
+          <a:lnRef idx="2">
+            <a:schemeClr val="accent1">
+              <a:shade val="15000"/>
+            </a:schemeClr>
+          </a:lnRef>
+          <a:fillRef idx="1">
+            <a:schemeClr val="accent1"/>
+          </a:fillRef>
+          <a:effectRef idx="0">
+            <a:schemeClr val="accent1"/>
+          </a:effectRef>
+          <a:fontRef idx="minor">
+            <a:schemeClr val="lt1"/>
+          </a:fontRef>
+        </p:style>
+        <p:txBody>
+          <a:bodyPr wrap="none" rtlCol="0" anchor="t" anchorCtr="0"/>
+          <a:lstStyle/>
+          <a:p>
+            <a:pPr algn="ctr"/>
+            <a:r>
+              <a:rPr lang="en-US" altLang="zh-CN" sz="1200" dirty="0">
+                <a:solidFill>
+                  <a:schemeClr val="tx1"/>
+                </a:solidFill>
+                <a:latin typeface="Times New Roman" panose="02020603050405020304" pitchFamily="18" charset="0"/>
+                <a:cs typeface="Times New Roman" panose="02020603050405020304" pitchFamily="18" charset="0"/>
+              </a:rPr>
+              <a:t>Mean across 8 heads</a:t>
+            </a:r>
+            <a:endParaRPr lang="en-US" sz="1200" dirty="0">
+              <a:solidFill>
+                <a:schemeClr val="tx1"/>
+              </a:solidFill>
+              <a:latin typeface="Times New Roman" panose="02020603050405020304" pitchFamily="18" charset="0"/>
+              <a:cs typeface="Times New Roman" panose="02020603050405020304" pitchFamily="18" charset="0"/>
+            </a:endParaRPr>
+          </a:p>
+        </p:txBody>
+      </p:sp>
+      <p:sp>
+        <p:nvSpPr>
+          <p:cNvPr id="21" name="Diamond 20">
+            <a:extLst>
+              <a:ext uri="{FF2B5EF4-FFF2-40B4-BE49-F238E27FC236}">
+                <a16:creationId xmlns:a16="http://schemas.microsoft.com/office/drawing/2014/main" id="{C1591A02-6C02-4208-762E-DBC5F1BA8787}"/>
+              </a:ext>
+            </a:extLst>
+          </p:cNvPr>
+          <p:cNvSpPr/>
+          <p:nvPr/>
+        </p:nvSpPr>
+        <p:spPr>
+          <a:xfrm>
+            <a:off x="4203525" y="4149696"/>
+            <a:ext cx="1124205" cy="739482"/>
+          </a:xfrm>
+          <a:prstGeom prst="diamond">
+            <a:avLst/>
+          </a:prstGeom>
+        </p:spPr>
+        <p:style>
+          <a:lnRef idx="2">
+            <a:schemeClr val="accent1">
+              <a:shade val="15000"/>
+            </a:schemeClr>
+          </a:lnRef>
+          <a:fillRef idx="1">
+            <a:schemeClr val="accent1"/>
+          </a:fillRef>
+          <a:effectRef idx="0">
+            <a:schemeClr val="accent1"/>
+          </a:effectRef>
+          <a:fontRef idx="minor">
+            <a:schemeClr val="lt1"/>
+          </a:fontRef>
+        </p:style>
+        <p:txBody>
+          <a:bodyPr lIns="0" tIns="0" rIns="0" bIns="0" rtlCol="0" anchor="ctr"/>
+          <a:lstStyle/>
+          <a:p>
+            <a:pPr algn="ctr"/>
+            <a:r>
+              <a:rPr lang="en-US" altLang="zh-CN" sz="1050" dirty="0"/>
+              <a:t>Len &gt;budget?</a:t>
+            </a:r>
+            <a:endParaRPr lang="en-US" sz="1050" dirty="0"/>
+          </a:p>
+        </p:txBody>
+      </p:sp>
+      <p:sp>
+        <p:nvSpPr>
+          <p:cNvPr id="22" name="Rectangle: Rounded Corners 21">
+            <a:extLst>
+              <a:ext uri="{FF2B5EF4-FFF2-40B4-BE49-F238E27FC236}">
+                <a16:creationId xmlns:a16="http://schemas.microsoft.com/office/drawing/2014/main" id="{C6CDA757-2051-2E3E-CCB6-1298869E4846}"/>
+              </a:ext>
+            </a:extLst>
+          </p:cNvPr>
+          <p:cNvSpPr/>
+          <p:nvPr/>
+        </p:nvSpPr>
+        <p:spPr>
+          <a:xfrm>
+            <a:off x="5258420" y="5282108"/>
+            <a:ext cx="1642557" cy="310633"/>
+          </a:xfrm>
+          <a:prstGeom prst="roundRect">
+            <a:avLst/>
+          </a:prstGeom>
+          <a:solidFill>
+            <a:srgbClr val="FFC000"/>
+          </a:solidFill>
+          <a:ln>
+            <a:solidFill>
+              <a:schemeClr val="bg1">
+                <a:lumMod val="50000"/>
+              </a:schemeClr>
+            </a:solidFill>
+          </a:ln>
+        </p:spPr>
+        <p:style>
+          <a:lnRef idx="2">
+            <a:schemeClr val="accent1">
+              <a:shade val="15000"/>
+            </a:schemeClr>
+          </a:lnRef>
+          <a:fillRef idx="1">
+            <a:schemeClr val="accent1"/>
+          </a:fillRef>
+          <a:effectRef idx="0">
+            <a:schemeClr val="accent1"/>
+          </a:effectRef>
+          <a:fontRef idx="minor">
+            <a:schemeClr val="lt1"/>
+          </a:fontRef>
+        </p:style>
+        <p:txBody>
+          <a:bodyPr wrap="none" rtlCol="0" anchor="t" anchorCtr="0"/>
+          <a:lstStyle/>
+          <a:p>
+            <a:pPr algn="ctr"/>
+            <a:r>
+              <a:rPr lang="en-US" altLang="zh-CN" sz="1200" dirty="0">
+                <a:solidFill>
+                  <a:schemeClr val="tx1"/>
+                </a:solidFill>
+                <a:latin typeface="Times New Roman" panose="02020603050405020304" pitchFamily="18" charset="0"/>
+                <a:cs typeface="Times New Roman" panose="02020603050405020304" pitchFamily="18" charset="0"/>
+              </a:rPr>
+              <a:t>Per head top K</a:t>
+            </a:r>
+            <a:endParaRPr lang="en-US" sz="1200" dirty="0">
+              <a:solidFill>
+                <a:schemeClr val="tx1"/>
+              </a:solidFill>
+              <a:latin typeface="Times New Roman" panose="02020603050405020304" pitchFamily="18" charset="0"/>
+              <a:cs typeface="Times New Roman" panose="02020603050405020304" pitchFamily="18" charset="0"/>
+            </a:endParaRPr>
+          </a:p>
+        </p:txBody>
+      </p:sp>
+      <p:sp>
+        <p:nvSpPr>
+          <p:cNvPr id="23" name="Rectangle: Rounded Corners 22">
+            <a:extLst>
+              <a:ext uri="{FF2B5EF4-FFF2-40B4-BE49-F238E27FC236}">
+                <a16:creationId xmlns:a16="http://schemas.microsoft.com/office/drawing/2014/main" id="{5F5346E4-FFFF-B1BF-8647-5F377902DDBB}"/>
+              </a:ext>
+            </a:extLst>
+          </p:cNvPr>
+          <p:cNvSpPr/>
+          <p:nvPr/>
+        </p:nvSpPr>
+        <p:spPr>
+          <a:xfrm>
+            <a:off x="3881222" y="6169308"/>
+            <a:ext cx="1768809" cy="310633"/>
+          </a:xfrm>
+          <a:prstGeom prst="roundRect">
+            <a:avLst/>
+          </a:prstGeom>
+          <a:solidFill>
+            <a:srgbClr val="FFC000"/>
+          </a:solidFill>
+          <a:ln>
+            <a:solidFill>
+              <a:schemeClr val="bg1">
+                <a:lumMod val="50000"/>
+              </a:schemeClr>
+            </a:solidFill>
+          </a:ln>
+        </p:spPr>
+        <p:style>
+          <a:lnRef idx="2">
+            <a:schemeClr val="accent1">
+              <a:shade val="15000"/>
+            </a:schemeClr>
+          </a:lnRef>
+          <a:fillRef idx="1">
+            <a:schemeClr val="accent1"/>
+          </a:fillRef>
+          <a:effectRef idx="0">
+            <a:schemeClr val="accent1"/>
+          </a:effectRef>
+          <a:fontRef idx="minor">
+            <a:schemeClr val="lt1"/>
+          </a:fontRef>
+        </p:style>
+        <p:txBody>
+          <a:bodyPr wrap="none" rtlCol="0" anchor="t" anchorCtr="0"/>
+          <a:lstStyle/>
+          <a:p>
+            <a:pPr algn="ctr"/>
+            <a:r>
+              <a:rPr lang="en-US" sz="1200" dirty="0">
+                <a:solidFill>
+                  <a:schemeClr val="tx1"/>
+                </a:solidFill>
+                <a:latin typeface="Times New Roman" panose="02020603050405020304" pitchFamily="18" charset="0"/>
+                <a:cs typeface="Times New Roman" panose="02020603050405020304" pitchFamily="18" charset="0"/>
+              </a:rPr>
+              <a:t>Aggregate and write back</a:t>
+            </a:r>
+          </a:p>
+        </p:txBody>
+      </p:sp>
+      <p:cxnSp>
+        <p:nvCxnSpPr>
+          <p:cNvPr id="25" name="Straight Arrow Connector 24">
+            <a:extLst>
+              <a:ext uri="{FF2B5EF4-FFF2-40B4-BE49-F238E27FC236}">
+                <a16:creationId xmlns:a16="http://schemas.microsoft.com/office/drawing/2014/main" id="{2127AEB9-DB0A-2767-3F1E-5CB53178C57B}"/>
+              </a:ext>
+            </a:extLst>
+          </p:cNvPr>
+          <p:cNvCxnSpPr>
+            <a:cxnSpLocks/>
+            <a:stCxn id="19" idx="2"/>
+            <a:endCxn id="21" idx="0"/>
+          </p:cNvCxnSpPr>
+          <p:nvPr/>
+        </p:nvCxnSpPr>
+        <p:spPr>
+          <a:xfrm>
+            <a:off x="4765627" y="3959367"/>
+            <a:ext cx="1" cy="190329"/>
+          </a:xfrm>
+          <a:prstGeom prst="straightConnector1">
+            <a:avLst/>
+          </a:prstGeom>
+          <a:ln>
+            <a:tailEnd type="triangle"/>
+          </a:ln>
+        </p:spPr>
+        <p:style>
+          <a:lnRef idx="2">
+            <a:schemeClr val="accent1"/>
+          </a:lnRef>
+          <a:fillRef idx="0">
+            <a:schemeClr val="accent1"/>
+          </a:fillRef>
+          <a:effectRef idx="1">
+            <a:schemeClr val="accent1"/>
+          </a:effectRef>
+          <a:fontRef idx="minor">
+            <a:schemeClr val="tx1"/>
+          </a:fontRef>
+        </p:style>
+      </p:cxnSp>
+      <p:cxnSp>
+        <p:nvCxnSpPr>
+          <p:cNvPr id="27" name="Straight Arrow Connector 26">
+            <a:extLst>
+              <a:ext uri="{FF2B5EF4-FFF2-40B4-BE49-F238E27FC236}">
+                <a16:creationId xmlns:a16="http://schemas.microsoft.com/office/drawing/2014/main" id="{58FC0AF4-C568-1521-E6A8-BC17BFDBADA0}"/>
+              </a:ext>
+            </a:extLst>
+          </p:cNvPr>
+          <p:cNvCxnSpPr>
+            <a:stCxn id="21" idx="2"/>
+            <a:endCxn id="20" idx="0"/>
+          </p:cNvCxnSpPr>
+          <p:nvPr/>
+        </p:nvCxnSpPr>
+        <p:spPr>
+          <a:xfrm flipH="1">
+            <a:off x="3451556" y="4889178"/>
+            <a:ext cx="1314072" cy="392930"/>
+          </a:xfrm>
+          <a:prstGeom prst="straightConnector1">
+            <a:avLst/>
+          </a:prstGeom>
+          <a:ln>
+            <a:tailEnd type="triangle"/>
+          </a:ln>
+        </p:spPr>
+        <p:style>
+          <a:lnRef idx="2">
+            <a:schemeClr val="accent1"/>
+          </a:lnRef>
+          <a:fillRef idx="0">
+            <a:schemeClr val="accent1"/>
+          </a:fillRef>
+          <a:effectRef idx="1">
+            <a:schemeClr val="accent1"/>
+          </a:effectRef>
+          <a:fontRef idx="minor">
+            <a:schemeClr val="tx1"/>
+          </a:fontRef>
+        </p:style>
+      </p:cxnSp>
+      <p:cxnSp>
+        <p:nvCxnSpPr>
+          <p:cNvPr id="28" name="Straight Arrow Connector 27">
+            <a:extLst>
+              <a:ext uri="{FF2B5EF4-FFF2-40B4-BE49-F238E27FC236}">
+                <a16:creationId xmlns:a16="http://schemas.microsoft.com/office/drawing/2014/main" id="{2B8E168E-93E4-4B79-904B-3D28715D67B1}"/>
+              </a:ext>
+            </a:extLst>
+          </p:cNvPr>
+          <p:cNvCxnSpPr>
+            <a:cxnSpLocks/>
+            <a:stCxn id="21" idx="2"/>
+            <a:endCxn id="22" idx="0"/>
+          </p:cNvCxnSpPr>
+          <p:nvPr/>
+        </p:nvCxnSpPr>
+        <p:spPr>
+          <a:xfrm>
+            <a:off x="4765628" y="4889178"/>
+            <a:ext cx="1314071" cy="392930"/>
+          </a:xfrm>
+          <a:prstGeom prst="straightConnector1">
+            <a:avLst/>
+          </a:prstGeom>
+          <a:ln>
+            <a:tailEnd type="triangle"/>
+          </a:ln>
+        </p:spPr>
+        <p:style>
+          <a:lnRef idx="2">
+            <a:schemeClr val="accent1"/>
+          </a:lnRef>
+          <a:fillRef idx="0">
+            <a:schemeClr val="accent1"/>
+          </a:fillRef>
+          <a:effectRef idx="1">
+            <a:schemeClr val="accent1"/>
+          </a:effectRef>
+          <a:fontRef idx="minor">
+            <a:schemeClr val="tx1"/>
+          </a:fontRef>
+        </p:style>
+      </p:cxnSp>
+      <p:cxnSp>
+        <p:nvCxnSpPr>
+          <p:cNvPr id="31" name="Straight Arrow Connector 30">
+            <a:extLst>
+              <a:ext uri="{FF2B5EF4-FFF2-40B4-BE49-F238E27FC236}">
+                <a16:creationId xmlns:a16="http://schemas.microsoft.com/office/drawing/2014/main" id="{C2DD3036-A9B4-0272-C0A0-0ECAC339BFD1}"/>
+              </a:ext>
+            </a:extLst>
+          </p:cNvPr>
+          <p:cNvCxnSpPr>
+            <a:cxnSpLocks/>
+            <a:stCxn id="22" idx="2"/>
+            <a:endCxn id="23" idx="0"/>
+          </p:cNvCxnSpPr>
+          <p:nvPr/>
+        </p:nvCxnSpPr>
+        <p:spPr>
+          <a:xfrm flipH="1">
+            <a:off x="4765627" y="5592741"/>
+            <a:ext cx="1314072" cy="576567"/>
+          </a:xfrm>
+          <a:prstGeom prst="straightConnector1">
+            <a:avLst/>
+          </a:prstGeom>
+          <a:ln>
+            <a:tailEnd type="triangle"/>
+          </a:ln>
+        </p:spPr>
+        <p:style>
+          <a:lnRef idx="2">
+            <a:schemeClr val="accent1"/>
+          </a:lnRef>
+          <a:fillRef idx="0">
+            <a:schemeClr val="accent1"/>
+          </a:fillRef>
+          <a:effectRef idx="1">
+            <a:schemeClr val="accent1"/>
+          </a:effectRef>
+          <a:fontRef idx="minor">
+            <a:schemeClr val="tx1"/>
+          </a:fontRef>
+        </p:style>
+      </p:cxnSp>
+      <p:cxnSp>
+        <p:nvCxnSpPr>
+          <p:cNvPr id="34" name="Straight Arrow Connector 33">
+            <a:extLst>
+              <a:ext uri="{FF2B5EF4-FFF2-40B4-BE49-F238E27FC236}">
+                <a16:creationId xmlns:a16="http://schemas.microsoft.com/office/drawing/2014/main" id="{56FD4DA9-396B-48BD-B8DC-ECA56274F43F}"/>
+              </a:ext>
+            </a:extLst>
+          </p:cNvPr>
+          <p:cNvCxnSpPr>
+            <a:cxnSpLocks/>
+            <a:stCxn id="20" idx="2"/>
+            <a:endCxn id="23" idx="0"/>
+          </p:cNvCxnSpPr>
+          <p:nvPr/>
+        </p:nvCxnSpPr>
+        <p:spPr>
+          <a:xfrm>
+            <a:off x="3451556" y="5592741"/>
+            <a:ext cx="1314071" cy="576567"/>
+          </a:xfrm>
+          <a:prstGeom prst="straightConnector1">
+            <a:avLst/>
+          </a:prstGeom>
+          <a:ln>
+            <a:tailEnd type="triangle"/>
+          </a:ln>
+        </p:spPr>
+        <p:style>
+          <a:lnRef idx="2">
+            <a:schemeClr val="accent1"/>
+          </a:lnRef>
+          <a:fillRef idx="0">
+            <a:schemeClr val="accent1"/>
+          </a:fillRef>
+          <a:effectRef idx="1">
+            <a:schemeClr val="accent1"/>
+          </a:effectRef>
+          <a:fontRef idx="minor">
+            <a:schemeClr val="tx1"/>
+          </a:fontRef>
+        </p:style>
+      </p:cxnSp>
+      <p:sp>
+        <p:nvSpPr>
+          <p:cNvPr id="37" name="Arrow: Curved Left 36">
+            <a:extLst>
+              <a:ext uri="{FF2B5EF4-FFF2-40B4-BE49-F238E27FC236}">
+                <a16:creationId xmlns:a16="http://schemas.microsoft.com/office/drawing/2014/main" id="{0B4AD2B2-C87C-319A-74E5-5DA2C7EE455C}"/>
+              </a:ext>
+            </a:extLst>
+          </p:cNvPr>
+          <p:cNvSpPr/>
+          <p:nvPr/>
+        </p:nvSpPr>
+        <p:spPr>
+          <a:xfrm rot="10800000">
+            <a:off x="2162713" y="3544434"/>
+            <a:ext cx="442335" cy="2624874"/>
+          </a:xfrm>
+          <a:prstGeom prst="curvedLeftArrow">
+            <a:avLst>
+              <a:gd name="adj1" fmla="val 22534"/>
+              <a:gd name="adj2" fmla="val 50000"/>
+              <a:gd name="adj3" fmla="val 25000"/>
+            </a:avLst>
+          </a:prstGeom>
+          <a:solidFill>
+            <a:srgbClr val="0070C0"/>
+          </a:solidFill>
+          <a:ln>
+            <a:solidFill>
+              <a:srgbClr val="002060"/>
+            </a:solidFill>
+          </a:ln>
+        </p:spPr>
+        <p:style>
+          <a:lnRef idx="2">
+            <a:schemeClr val="accent1">
+              <a:shade val="15000"/>
+            </a:schemeClr>
+          </a:lnRef>
+          <a:fillRef idx="1">
+            <a:schemeClr val="accent1"/>
+          </a:fillRef>
+          <a:effectRef idx="0">
+            <a:schemeClr val="accent1"/>
+          </a:effectRef>
+          <a:fontRef idx="minor">
+            <a:schemeClr val="lt1"/>
+          </a:fontRef>
+        </p:style>
+        <p:txBody>
+          <a:bodyPr rtlCol="0" anchor="ctr"/>
+          <a:lstStyle/>
+          <a:p>
+            <a:pPr algn="ctr"/>
+            <a:endParaRPr lang="en-US">
+              <a:solidFill>
+                <a:schemeClr val="tx1"/>
+              </a:solidFill>
+            </a:endParaRPr>
+          </a:p>
+        </p:txBody>
+      </p:sp>
+      <p:sp>
+        <p:nvSpPr>
+          <p:cNvPr id="38" name="Arrow: Down 37">
+            <a:extLst>
+              <a:ext uri="{FF2B5EF4-FFF2-40B4-BE49-F238E27FC236}">
+                <a16:creationId xmlns:a16="http://schemas.microsoft.com/office/drawing/2014/main" id="{C6ED8D7B-1D58-AEAF-3D1B-8D4F91A03E47}"/>
+              </a:ext>
+            </a:extLst>
+          </p:cNvPr>
+          <p:cNvSpPr/>
+          <p:nvPr/>
+        </p:nvSpPr>
+        <p:spPr>
+          <a:xfrm rot="16200000">
+            <a:off x="4503554" y="479619"/>
+            <a:ext cx="310634" cy="255303"/>
+          </a:xfrm>
+          <a:prstGeom prst="downArrow">
+            <a:avLst/>
+          </a:prstGeom>
+          <a:solidFill>
+            <a:schemeClr val="accent2">
+              <a:lumMod val="20000"/>
+              <a:lumOff val="80000"/>
+            </a:schemeClr>
+          </a:solidFill>
+          <a:ln>
+            <a:solidFill>
+              <a:schemeClr val="accent2">
+                <a:lumMod val="75000"/>
+              </a:schemeClr>
+            </a:solidFill>
+          </a:ln>
+        </p:spPr>
+        <p:style>
+          <a:lnRef idx="2">
+            <a:schemeClr val="accent1">
+              <a:shade val="15000"/>
+            </a:schemeClr>
+          </a:lnRef>
+          <a:fillRef idx="1">
+            <a:schemeClr val="accent1"/>
+          </a:fillRef>
+          <a:effectRef idx="0">
+            <a:schemeClr val="accent1"/>
+          </a:effectRef>
+          <a:fontRef idx="minor">
+            <a:schemeClr val="lt1"/>
+          </a:fontRef>
+        </p:style>
+        <p:txBody>
+          <a:bodyPr rtlCol="0" anchor="ctr"/>
+          <a:lstStyle/>
+          <a:p>
+            <a:pPr algn="ctr"/>
+            <a:endParaRPr lang="en-US" sz="1200" b="1">
+              <a:solidFill>
+                <a:schemeClr val="tx1">
+                  <a:lumMod val="95000"/>
+                  <a:lumOff val="5000"/>
+                </a:schemeClr>
+              </a:solidFill>
+              <a:latin typeface="Times New Roman" panose="02020603050405020304" pitchFamily="18" charset="0"/>
+              <a:cs typeface="Times New Roman" panose="02020603050405020304" pitchFamily="18" charset="0"/>
+            </a:endParaRPr>
+          </a:p>
+        </p:txBody>
+      </p:sp>
+      <p:sp>
+        <p:nvSpPr>
+          <p:cNvPr id="40" name="Arrow: Down 39">
+            <a:extLst>
+              <a:ext uri="{FF2B5EF4-FFF2-40B4-BE49-F238E27FC236}">
+                <a16:creationId xmlns:a16="http://schemas.microsoft.com/office/drawing/2014/main" id="{9B02F374-5D96-1A63-0640-B267C088AA16}"/>
+              </a:ext>
+            </a:extLst>
+          </p:cNvPr>
+          <p:cNvSpPr/>
+          <p:nvPr/>
+        </p:nvSpPr>
+        <p:spPr>
+          <a:xfrm rot="16200000">
+            <a:off x="4503554" y="1248450"/>
+            <a:ext cx="310634" cy="255303"/>
+          </a:xfrm>
+          <a:prstGeom prst="downArrow">
+            <a:avLst/>
+          </a:prstGeom>
+          <a:solidFill>
+            <a:schemeClr val="bg2"/>
+          </a:solidFill>
+          <a:ln>
+            <a:solidFill>
+              <a:schemeClr val="bg1">
+                <a:lumMod val="75000"/>
+              </a:schemeClr>
+            </a:solidFill>
+          </a:ln>
+        </p:spPr>
+        <p:style>
+          <a:lnRef idx="2">
+            <a:schemeClr val="accent1">
+              <a:shade val="15000"/>
+            </a:schemeClr>
+          </a:lnRef>
+          <a:fillRef idx="1">
+            <a:schemeClr val="accent1"/>
+          </a:fillRef>
+          <a:effectRef idx="0">
+            <a:schemeClr val="accent1"/>
+          </a:effectRef>
+          <a:fontRef idx="minor">
+            <a:schemeClr val="lt1"/>
+          </a:fontRef>
+        </p:style>
+        <p:txBody>
+          <a:bodyPr rtlCol="0" anchor="ctr"/>
+          <a:lstStyle/>
+          <a:p>
+            <a:pPr algn="ctr"/>
+            <a:endParaRPr lang="en-US" sz="1200" b="1">
+              <a:solidFill>
+                <a:schemeClr val="tx1">
+                  <a:lumMod val="95000"/>
+                  <a:lumOff val="5000"/>
+                </a:schemeClr>
+              </a:solidFill>
+              <a:latin typeface="Times New Roman" panose="02020603050405020304" pitchFamily="18" charset="0"/>
+              <a:cs typeface="Times New Roman" panose="02020603050405020304" pitchFamily="18" charset="0"/>
+            </a:endParaRPr>
+          </a:p>
+        </p:txBody>
+      </p:sp>
+      <p:sp>
+        <p:nvSpPr>
+          <p:cNvPr id="41" name="Arrow: Down 40">
+            <a:extLst>
+              <a:ext uri="{FF2B5EF4-FFF2-40B4-BE49-F238E27FC236}">
+                <a16:creationId xmlns:a16="http://schemas.microsoft.com/office/drawing/2014/main" id="{519B6608-365B-8A25-727F-50EF376A3F4A}"/>
+              </a:ext>
+            </a:extLst>
+          </p:cNvPr>
+          <p:cNvSpPr/>
+          <p:nvPr/>
+        </p:nvSpPr>
+        <p:spPr>
+          <a:xfrm rot="16200000">
+            <a:off x="4503554" y="2363412"/>
+            <a:ext cx="310634" cy="255303"/>
+          </a:xfrm>
+          <a:prstGeom prst="downArrow">
+            <a:avLst/>
+          </a:prstGeom>
+          <a:solidFill>
+            <a:schemeClr val="accent1">
+              <a:lumMod val="20000"/>
+              <a:lumOff val="80000"/>
+            </a:schemeClr>
+          </a:solidFill>
+          <a:ln>
+            <a:solidFill>
+              <a:schemeClr val="tx2">
+                <a:lumMod val="90000"/>
+                <a:lumOff val="10000"/>
+              </a:schemeClr>
+            </a:solidFill>
+          </a:ln>
+        </p:spPr>
+        <p:style>
+          <a:lnRef idx="2">
+            <a:schemeClr val="accent1">
+              <a:shade val="15000"/>
+            </a:schemeClr>
+          </a:lnRef>
+          <a:fillRef idx="1">
+            <a:schemeClr val="accent1"/>
+          </a:fillRef>
+          <a:effectRef idx="0">
+            <a:schemeClr val="accent1"/>
+          </a:effectRef>
+          <a:fontRef idx="minor">
+            <a:schemeClr val="lt1"/>
+          </a:fontRef>
+        </p:style>
+        <p:txBody>
+          <a:bodyPr wrap="none" rtlCol="0" anchor="t" anchorCtr="0"/>
+          <a:lstStyle/>
+          <a:p>
+            <a:pPr algn="ctr"/>
+            <a:endParaRPr lang="en-US" sz="1200" b="1">
+              <a:solidFill>
+                <a:schemeClr val="tx1">
+                  <a:lumMod val="95000"/>
+                  <a:lumOff val="5000"/>
+                </a:schemeClr>
+              </a:solidFill>
+              <a:latin typeface="Times New Roman" panose="02020603050405020304" pitchFamily="18" charset="0"/>
+              <a:cs typeface="Times New Roman" panose="02020603050405020304" pitchFamily="18" charset="0"/>
+            </a:endParaRPr>
+          </a:p>
+        </p:txBody>
+      </p:sp>
+      <p:cxnSp>
+        <p:nvCxnSpPr>
+          <p:cNvPr id="42" name="Straight Arrow Connector 41">
+            <a:extLst>
+              <a:ext uri="{FF2B5EF4-FFF2-40B4-BE49-F238E27FC236}">
+                <a16:creationId xmlns:a16="http://schemas.microsoft.com/office/drawing/2014/main" id="{7F0A3BF6-0236-45B6-2108-889061763832}"/>
+              </a:ext>
+            </a:extLst>
+          </p:cNvPr>
+          <p:cNvCxnSpPr>
+            <a:cxnSpLocks/>
+            <a:stCxn id="23" idx="1"/>
+            <a:endCxn id="37" idx="0"/>
+          </p:cNvCxnSpPr>
+          <p:nvPr/>
+        </p:nvCxnSpPr>
+        <p:spPr>
+          <a:xfrm flipH="1" flipV="1">
+            <a:off x="2605048" y="6119470"/>
+            <a:ext cx="1276174" cy="205155"/>
+          </a:xfrm>
+          <a:prstGeom prst="straightConnector1">
+            <a:avLst/>
+          </a:prstGeom>
+          <a:ln>
+            <a:tailEnd type="triangle"/>
+          </a:ln>
+        </p:spPr>
+        <p:style>
+          <a:lnRef idx="2">
+            <a:schemeClr val="accent1"/>
+          </a:lnRef>
+          <a:fillRef idx="0">
+            <a:schemeClr val="accent1"/>
+          </a:fillRef>
+          <a:effectRef idx="1">
+            <a:schemeClr val="accent1"/>
+          </a:effectRef>
+          <a:fontRef idx="minor">
+            <a:schemeClr val="tx1"/>
+          </a:fontRef>
+        </p:style>
+      </p:cxnSp>
+      <p:cxnSp>
+        <p:nvCxnSpPr>
+          <p:cNvPr id="72" name="Straight Connector 71">
+            <a:extLst>
+              <a:ext uri="{FF2B5EF4-FFF2-40B4-BE49-F238E27FC236}">
+                <a16:creationId xmlns:a16="http://schemas.microsoft.com/office/drawing/2014/main" id="{5377CD0E-C736-ED09-8A05-49E45AE78454}"/>
+              </a:ext>
+            </a:extLst>
+          </p:cNvPr>
+          <p:cNvCxnSpPr/>
+          <p:nvPr/>
+        </p:nvCxnSpPr>
+        <p:spPr>
+          <a:xfrm>
+            <a:off x="192230" y="998220"/>
+            <a:ext cx="8692690" cy="0"/>
+          </a:xfrm>
+          <a:prstGeom prst="line">
+            <a:avLst/>
+          </a:prstGeom>
+          <a:ln w="38100">
+            <a:solidFill>
+              <a:schemeClr val="tx1"/>
+            </a:solidFill>
+            <a:prstDash val="sysDot"/>
+            <a:headEnd type="diamond" w="med" len="med"/>
+            <a:tailEnd type="diamond" w="med" len="med"/>
+          </a:ln>
+        </p:spPr>
+        <p:style>
+          <a:lnRef idx="2">
+            <a:schemeClr val="accent1"/>
+          </a:lnRef>
+          <a:fillRef idx="0">
+            <a:schemeClr val="accent1"/>
+          </a:fillRef>
+          <a:effectRef idx="1">
+            <a:schemeClr val="accent1"/>
+          </a:effectRef>
+          <a:fontRef idx="minor">
+            <a:schemeClr val="tx1"/>
+          </a:fontRef>
+        </p:style>
+      </p:cxnSp>
+      <p:cxnSp>
+        <p:nvCxnSpPr>
+          <p:cNvPr id="73" name="Straight Connector 72">
+            <a:extLst>
+              <a:ext uri="{FF2B5EF4-FFF2-40B4-BE49-F238E27FC236}">
+                <a16:creationId xmlns:a16="http://schemas.microsoft.com/office/drawing/2014/main" id="{7DC87FDF-C3C6-2021-3834-7C73D38488E5}"/>
+              </a:ext>
+            </a:extLst>
+          </p:cNvPr>
+          <p:cNvCxnSpPr/>
+          <p:nvPr/>
+        </p:nvCxnSpPr>
+        <p:spPr>
+          <a:xfrm>
+            <a:off x="192230" y="1882140"/>
+            <a:ext cx="8692690" cy="0"/>
+          </a:xfrm>
+          <a:prstGeom prst="line">
+            <a:avLst/>
+          </a:prstGeom>
+          <a:ln w="38100">
+            <a:solidFill>
+              <a:schemeClr val="tx1"/>
+            </a:solidFill>
+            <a:prstDash val="sysDot"/>
+            <a:headEnd type="diamond" w="med" len="med"/>
+            <a:tailEnd type="diamond" w="med" len="med"/>
+          </a:ln>
+        </p:spPr>
+        <p:style>
+          <a:lnRef idx="2">
+            <a:schemeClr val="accent1"/>
+          </a:lnRef>
+          <a:fillRef idx="0">
+            <a:schemeClr val="accent1"/>
+          </a:fillRef>
+          <a:effectRef idx="1">
+            <a:schemeClr val="accent1"/>
+          </a:effectRef>
+          <a:fontRef idx="minor">
+            <a:schemeClr val="tx1"/>
+          </a:fontRef>
+        </p:style>
+      </p:cxnSp>
+      <p:cxnSp>
+        <p:nvCxnSpPr>
+          <p:cNvPr id="74" name="Straight Connector 73">
+            <a:extLst>
+              <a:ext uri="{FF2B5EF4-FFF2-40B4-BE49-F238E27FC236}">
+                <a16:creationId xmlns:a16="http://schemas.microsoft.com/office/drawing/2014/main" id="{DBBCD4D6-839D-AAC0-406F-CD3D56454342}"/>
+              </a:ext>
+            </a:extLst>
+          </p:cNvPr>
+          <p:cNvCxnSpPr/>
+          <p:nvPr/>
+        </p:nvCxnSpPr>
+        <p:spPr>
+          <a:xfrm>
+            <a:off x="192230" y="3131820"/>
+            <a:ext cx="8692690" cy="0"/>
+          </a:xfrm>
+          <a:prstGeom prst="line">
+            <a:avLst/>
+          </a:prstGeom>
+          <a:ln w="38100">
+            <a:solidFill>
+              <a:schemeClr val="tx1"/>
+            </a:solidFill>
+            <a:prstDash val="sysDot"/>
+            <a:headEnd type="diamond" w="med" len="med"/>
+            <a:tailEnd type="diamond" w="med" len="med"/>
+          </a:ln>
+        </p:spPr>
+        <p:style>
+          <a:lnRef idx="2">
+            <a:schemeClr val="accent1"/>
+          </a:lnRef>
+          <a:fillRef idx="0">
+            <a:schemeClr val="accent1"/>
+          </a:fillRef>
+          <a:effectRef idx="1">
+            <a:schemeClr val="accent1"/>
+          </a:effectRef>
+          <a:fontRef idx="minor">
+            <a:schemeClr val="tx1"/>
+          </a:fontRef>
+        </p:style>
+      </p:cxnSp>
+      <p:sp>
+        <p:nvSpPr>
+          <p:cNvPr id="75" name="Arrow: Down 74">
+            <a:extLst>
+              <a:ext uri="{FF2B5EF4-FFF2-40B4-BE49-F238E27FC236}">
+                <a16:creationId xmlns:a16="http://schemas.microsoft.com/office/drawing/2014/main" id="{F8BFEA2A-5309-8711-A3A1-3A4453821681}"/>
+              </a:ext>
+            </a:extLst>
+          </p:cNvPr>
+          <p:cNvSpPr/>
+          <p:nvPr/>
+        </p:nvSpPr>
+        <p:spPr>
+          <a:xfrm>
+            <a:off x="8330329" y="609822"/>
+            <a:ext cx="313938" cy="775351"/>
+          </a:xfrm>
+          <a:prstGeom prst="downArrow">
+            <a:avLst/>
+          </a:prstGeom>
+          <a:solidFill>
+            <a:schemeClr val="accent2">
+              <a:lumMod val="20000"/>
+              <a:lumOff val="80000"/>
+            </a:schemeClr>
+          </a:solidFill>
+          <a:ln>
+            <a:solidFill>
+              <a:schemeClr val="accent2">
+                <a:lumMod val="75000"/>
+              </a:schemeClr>
+            </a:solidFill>
+          </a:ln>
+        </p:spPr>
+        <p:style>
+          <a:lnRef idx="2">
+            <a:schemeClr val="accent1">
+              <a:shade val="15000"/>
+            </a:schemeClr>
+          </a:lnRef>
+          <a:fillRef idx="1">
+            <a:schemeClr val="accent1"/>
+          </a:fillRef>
+          <a:effectRef idx="0">
+            <a:schemeClr val="accent1"/>
+          </a:effectRef>
+          <a:fontRef idx="minor">
+            <a:schemeClr val="lt1"/>
+          </a:fontRef>
+        </p:style>
+        <p:txBody>
+          <a:bodyPr rtlCol="0" anchor="ctr"/>
+          <a:lstStyle/>
+          <a:p>
+            <a:pPr algn="ctr"/>
+            <a:endParaRPr lang="en-US" sz="1200" b="1">
+              <a:solidFill>
+                <a:schemeClr val="tx1">
+                  <a:lumMod val="95000"/>
+                  <a:lumOff val="5000"/>
+                </a:schemeClr>
+              </a:solidFill>
+              <a:latin typeface="Times New Roman" panose="02020603050405020304" pitchFamily="18" charset="0"/>
+              <a:cs typeface="Times New Roman" panose="02020603050405020304" pitchFamily="18" charset="0"/>
+            </a:endParaRPr>
+          </a:p>
+        </p:txBody>
+      </p:sp>
+      <p:sp>
+        <p:nvSpPr>
+          <p:cNvPr id="76" name="Arrow: Down 75">
+            <a:extLst>
+              <a:ext uri="{FF2B5EF4-FFF2-40B4-BE49-F238E27FC236}">
+                <a16:creationId xmlns:a16="http://schemas.microsoft.com/office/drawing/2014/main" id="{77D4E3E6-D0A0-FD6E-FB42-5264AF2BF1B7}"/>
+              </a:ext>
+            </a:extLst>
+          </p:cNvPr>
+          <p:cNvSpPr/>
+          <p:nvPr/>
+        </p:nvSpPr>
+        <p:spPr>
+          <a:xfrm>
+            <a:off x="8330329" y="1504734"/>
+            <a:ext cx="313938" cy="775351"/>
+          </a:xfrm>
+          <a:prstGeom prst="downArrow">
+            <a:avLst/>
+          </a:prstGeom>
+          <a:solidFill>
+            <a:schemeClr val="bg2"/>
+          </a:solidFill>
+          <a:ln>
+            <a:solidFill>
+              <a:schemeClr val="bg1">
+                <a:lumMod val="75000"/>
+              </a:schemeClr>
+            </a:solidFill>
+          </a:ln>
+        </p:spPr>
+        <p:style>
+          <a:lnRef idx="2">
+            <a:schemeClr val="accent1">
+              <a:shade val="15000"/>
+            </a:schemeClr>
+          </a:lnRef>
+          <a:fillRef idx="1">
+            <a:schemeClr val="accent1"/>
+          </a:fillRef>
+          <a:effectRef idx="0">
+            <a:schemeClr val="accent1"/>
+          </a:effectRef>
+          <a:fontRef idx="minor">
+            <a:schemeClr val="lt1"/>
+          </a:fontRef>
+        </p:style>
+        <p:txBody>
+          <a:bodyPr rtlCol="0" anchor="ctr"/>
+          <a:lstStyle/>
+          <a:p>
+            <a:pPr algn="ctr"/>
+            <a:endParaRPr lang="en-US" sz="1200" b="1">
+              <a:solidFill>
+                <a:schemeClr val="tx1">
+                  <a:lumMod val="95000"/>
+                  <a:lumOff val="5000"/>
+                </a:schemeClr>
+              </a:solidFill>
+              <a:latin typeface="Times New Roman" panose="02020603050405020304" pitchFamily="18" charset="0"/>
+              <a:cs typeface="Times New Roman" panose="02020603050405020304" pitchFamily="18" charset="0"/>
+            </a:endParaRPr>
+          </a:p>
+        </p:txBody>
+      </p:sp>
+      <p:sp>
+        <p:nvSpPr>
+          <p:cNvPr id="77" name="Arrow: Down 76">
+            <a:extLst>
+              <a:ext uri="{FF2B5EF4-FFF2-40B4-BE49-F238E27FC236}">
+                <a16:creationId xmlns:a16="http://schemas.microsoft.com/office/drawing/2014/main" id="{D468F106-B73C-F50F-3445-F9BBF76C2C9B}"/>
+              </a:ext>
+            </a:extLst>
+          </p:cNvPr>
+          <p:cNvSpPr/>
+          <p:nvPr/>
+        </p:nvSpPr>
+        <p:spPr>
+          <a:xfrm>
+            <a:off x="8336567" y="2745227"/>
+            <a:ext cx="313938" cy="775351"/>
+          </a:xfrm>
+          <a:prstGeom prst="downArrow">
+            <a:avLst/>
+          </a:prstGeom>
+          <a:solidFill>
+            <a:schemeClr val="accent1">
+              <a:lumMod val="20000"/>
+              <a:lumOff val="80000"/>
+            </a:schemeClr>
+          </a:solidFill>
+          <a:ln>
+            <a:solidFill>
+              <a:schemeClr val="tx2">
+                <a:lumMod val="90000"/>
+                <a:lumOff val="10000"/>
+              </a:schemeClr>
+            </a:solidFill>
+          </a:ln>
+        </p:spPr>
+        <p:style>
+          <a:lnRef idx="2">
+            <a:schemeClr val="accent1">
+              <a:shade val="15000"/>
+            </a:schemeClr>
+          </a:lnRef>
+          <a:fillRef idx="1">
+            <a:schemeClr val="accent1"/>
+          </a:fillRef>
+          <a:effectRef idx="0">
+            <a:schemeClr val="accent1"/>
+          </a:effectRef>
+          <a:fontRef idx="minor">
+            <a:schemeClr val="lt1"/>
+          </a:fontRef>
+        </p:style>
+        <p:txBody>
+          <a:bodyPr wrap="none" rtlCol="0" anchor="t" anchorCtr="0"/>
+          <a:lstStyle/>
+          <a:p>
+            <a:pPr algn="ctr"/>
+            <a:endParaRPr lang="en-US" sz="1200" b="1">
+              <a:solidFill>
+                <a:schemeClr val="tx1">
+                  <a:lumMod val="95000"/>
+                  <a:lumOff val="5000"/>
+                </a:schemeClr>
+              </a:solidFill>
+              <a:latin typeface="Times New Roman" panose="02020603050405020304" pitchFamily="18" charset="0"/>
+              <a:cs typeface="Times New Roman" panose="02020603050405020304" pitchFamily="18" charset="0"/>
+            </a:endParaRPr>
+          </a:p>
+        </p:txBody>
+      </p:sp>
+    </p:spTree>
+    <p:extLst>
+      <p:ext uri="{BB962C8B-B14F-4D97-AF65-F5344CB8AC3E}">
+        <p14:creationId xmlns:p14="http://schemas.microsoft.com/office/powerpoint/2010/main" val="2852120370"/>
+      </p:ext>
+    </p:extLst>
+  </p:cSld>
+  <p:clrMapOvr>
+    <a:masterClrMapping/>
+  </p:clrMapOvr>
+</p:sld>
+</file>
+
+<file path=ppt/slides/slide4.xml><?xml version="1.0" encoding="utf-8"?>
+<p:sld xmlns:a="http://schemas.openxmlformats.org/drawingml/2006/main" xmlns:r="http://schemas.openxmlformats.org/officeDocument/2006/relationships" xmlns:p="http://schemas.openxmlformats.org/presentationml/2006/main">
+  <p:cSld>
+    <p:spTree>
+      <p:nvGrpSpPr>
+        <p:cNvPr id="1" name=""/>
+        <p:cNvGrpSpPr/>
+        <p:nvPr/>
+      </p:nvGrpSpPr>
+      <p:grpSpPr>
+        <a:xfrm>
+          <a:off x="0" y="0"/>
+          <a:ext cx="0" cy="0"/>
+          <a:chOff x="0" y="0"/>
+          <a:chExt cx="0" cy="0"/>
+        </a:xfrm>
+      </p:grpSpPr>
+      <p:pic>
+        <p:nvPicPr>
+          <p:cNvPr id="5" name="Content Placeholder 4" descr="A diagram of a diagram&#10;&#10;AI-generated content may be incorrect.">
+            <a:extLst>
+              <a:ext uri="{FF2B5EF4-FFF2-40B4-BE49-F238E27FC236}">
+                <a16:creationId xmlns:a16="http://schemas.microsoft.com/office/drawing/2014/main" id="{78163D41-08F5-36C2-4763-4E846D9E014E}"/>
+              </a:ext>
+            </a:extLst>
+          </p:cNvPr>
+          <p:cNvPicPr>
+            <a:picLocks noGrp="1" noChangeAspect="1"/>
+          </p:cNvPicPr>
+          <p:nvPr>
+            <p:ph idx="1"/>
+          </p:nvPr>
+        </p:nvPicPr>
+        <p:blipFill>
+          <a:blip r:embed="rId2">
+            <a:extLst>
+              <a:ext uri="{28A0092B-C50C-407E-A947-70E740481C1C}">
+                <a14:useLocalDpi xmlns:a14="http://schemas.microsoft.com/office/drawing/2010/main" val="0"/>
+              </a:ext>
+            </a:extLst>
+          </a:blip>
+          <a:stretch>
+            <a:fillRect/>
+          </a:stretch>
+        </p:blipFill>
+        <p:spPr>
+          <a:xfrm>
+            <a:off x="2050611" y="374808"/>
+            <a:ext cx="5987504" cy="6108383"/>
+          </a:xfrm>
+        </p:spPr>
+      </p:pic>
+      <p:sp>
+        <p:nvSpPr>
+          <p:cNvPr id="6" name="Rectangle: Rounded Corners 5">
+            <a:extLst>
+              <a:ext uri="{FF2B5EF4-FFF2-40B4-BE49-F238E27FC236}">
+                <a16:creationId xmlns:a16="http://schemas.microsoft.com/office/drawing/2014/main" id="{E156A2C7-3385-4AE5-86EE-9276DF9DEB00}"/>
+              </a:ext>
+            </a:extLst>
+          </p:cNvPr>
+          <p:cNvSpPr/>
+          <p:nvPr/>
+        </p:nvSpPr>
+        <p:spPr>
+          <a:xfrm>
+            <a:off x="6096000" y="4293704"/>
+            <a:ext cx="3140765" cy="708992"/>
+          </a:xfrm>
+          <a:prstGeom prst="roundRect">
+            <a:avLst/>
+          </a:prstGeom>
+        </p:spPr>
+        <p:style>
+          <a:lnRef idx="2">
+            <a:schemeClr val="accent1">
+              <a:shade val="15000"/>
+            </a:schemeClr>
+          </a:lnRef>
+          <a:fillRef idx="1">
+            <a:schemeClr val="accent1"/>
+          </a:fillRef>
+          <a:effectRef idx="0">
+            <a:schemeClr val="accent1"/>
+          </a:effectRef>
+          <a:fontRef idx="minor">
+            <a:schemeClr val="lt1"/>
+          </a:fontRef>
+        </p:style>
+        <p:txBody>
+          <a:bodyPr rtlCol="0" anchor="ctr"/>
+          <a:lstStyle/>
+          <a:p>
+            <a:pPr algn="ctr"/>
+            <a:r>
+              <a:rPr lang="en-US" dirty="0"/>
+              <a:t>Force </a:t>
+            </a:r>
+            <a:r>
+              <a:rPr lang="en-US" dirty="0" err="1"/>
+              <a:t>output_attentions</a:t>
+            </a:r>
+            <a:r>
+              <a:rPr lang="en-US" dirty="0"/>
+              <a:t> </a:t>
+            </a:r>
+          </a:p>
+          <a:p>
+            <a:pPr algn="ctr"/>
+            <a:r>
+              <a:rPr lang="en-US" dirty="0" err="1"/>
+              <a:t>Acc_scores</a:t>
+            </a:r>
+            <a:r>
+              <a:rPr lang="en-US" dirty="0"/>
+              <a:t> accumulation</a:t>
+            </a:r>
+          </a:p>
+        </p:txBody>
+      </p:sp>
+      <p:sp>
+        <p:nvSpPr>
+          <p:cNvPr id="7" name="Rectangle: Rounded Corners 6">
+            <a:extLst>
+              <a:ext uri="{FF2B5EF4-FFF2-40B4-BE49-F238E27FC236}">
+                <a16:creationId xmlns:a16="http://schemas.microsoft.com/office/drawing/2014/main" id="{EE3F97BF-AA7B-2EE8-B9DD-4AA2349B5B8E}"/>
+              </a:ext>
+            </a:extLst>
+          </p:cNvPr>
+          <p:cNvSpPr/>
+          <p:nvPr/>
+        </p:nvSpPr>
+        <p:spPr>
+          <a:xfrm>
+            <a:off x="86140" y="1424608"/>
+            <a:ext cx="3140765" cy="708992"/>
+          </a:xfrm>
+          <a:prstGeom prst="roundRect">
+            <a:avLst/>
+          </a:prstGeom>
+        </p:spPr>
+        <p:style>
+          <a:lnRef idx="2">
+            <a:schemeClr val="accent1">
+              <a:shade val="15000"/>
+            </a:schemeClr>
+          </a:lnRef>
+          <a:fillRef idx="1">
+            <a:schemeClr val="accent1"/>
+          </a:fillRef>
+          <a:effectRef idx="0">
+            <a:schemeClr val="accent1"/>
+          </a:effectRef>
+          <a:fontRef idx="minor">
+            <a:schemeClr val="lt1"/>
+          </a:fontRef>
+        </p:style>
+        <p:txBody>
+          <a:bodyPr rtlCol="0" anchor="ctr"/>
+          <a:lstStyle/>
+          <a:p>
+            <a:pPr algn="ctr"/>
+            <a:r>
+              <a:rPr lang="en-US" dirty="0"/>
+              <a:t>Update </a:t>
+            </a:r>
+            <a:r>
+              <a:rPr lang="en-US" dirty="0" err="1"/>
+              <a:t>past_key_values</a:t>
+            </a:r>
+            <a:endParaRPr lang="en-US" dirty="0"/>
+          </a:p>
+        </p:txBody>
+      </p:sp>
+      <p:cxnSp>
+        <p:nvCxnSpPr>
+          <p:cNvPr id="9" name="Straight Arrow Connector 8">
+            <a:extLst>
+              <a:ext uri="{FF2B5EF4-FFF2-40B4-BE49-F238E27FC236}">
+                <a16:creationId xmlns:a16="http://schemas.microsoft.com/office/drawing/2014/main" id="{99774631-AD98-50FA-D418-E7E8EED0FF35}"/>
+              </a:ext>
+            </a:extLst>
+          </p:cNvPr>
+          <p:cNvCxnSpPr>
+            <a:cxnSpLocks/>
+            <a:stCxn id="7" idx="3"/>
+          </p:cNvCxnSpPr>
+          <p:nvPr/>
+        </p:nvCxnSpPr>
+        <p:spPr>
+          <a:xfrm>
+            <a:off x="3226905" y="1779104"/>
+            <a:ext cx="1378225" cy="268357"/>
+          </a:xfrm>
+          <a:prstGeom prst="straightConnector1">
+            <a:avLst/>
+          </a:prstGeom>
+          <a:ln>
+            <a:headEnd type="triangle"/>
+            <a:tailEnd type="triangle"/>
+          </a:ln>
+        </p:spPr>
+        <p:style>
+          <a:lnRef idx="2">
+            <a:schemeClr val="accent1"/>
+          </a:lnRef>
+          <a:fillRef idx="0">
+            <a:schemeClr val="accent1"/>
+          </a:fillRef>
+          <a:effectRef idx="1">
+            <a:schemeClr val="accent1"/>
+          </a:effectRef>
+          <a:fontRef idx="minor">
+            <a:schemeClr val="tx1"/>
+          </a:fontRef>
+        </p:style>
+      </p:cxnSp>
+      <p:cxnSp>
+        <p:nvCxnSpPr>
+          <p:cNvPr id="10" name="Straight Arrow Connector 9">
+            <a:extLst>
+              <a:ext uri="{FF2B5EF4-FFF2-40B4-BE49-F238E27FC236}">
+                <a16:creationId xmlns:a16="http://schemas.microsoft.com/office/drawing/2014/main" id="{7B044D32-C22C-B3F2-E933-4DCF2F108C77}"/>
+              </a:ext>
+            </a:extLst>
+          </p:cNvPr>
+          <p:cNvCxnSpPr>
+            <a:cxnSpLocks/>
+          </p:cNvCxnSpPr>
+          <p:nvPr/>
+        </p:nvCxnSpPr>
+        <p:spPr>
+          <a:xfrm flipH="1" flipV="1">
+            <a:off x="5044363" y="4015409"/>
+            <a:ext cx="1051637" cy="632791"/>
+          </a:xfrm>
+          <a:prstGeom prst="straightConnector1">
+            <a:avLst/>
+          </a:prstGeom>
+          <a:ln>
+            <a:headEnd type="triangle"/>
+            <a:tailEnd type="triangle"/>
+          </a:ln>
+        </p:spPr>
+        <p:style>
+          <a:lnRef idx="2">
+            <a:schemeClr val="accent1"/>
+          </a:lnRef>
+          <a:fillRef idx="0">
+            <a:schemeClr val="accent1"/>
+          </a:fillRef>
+          <a:effectRef idx="1">
+            <a:schemeClr val="accent1"/>
+          </a:effectRef>
+          <a:fontRef idx="minor">
+            <a:schemeClr val="tx1"/>
+          </a:fontRef>
+        </p:style>
+      </p:cxnSp>
+    </p:spTree>
+    <p:extLst>
+      <p:ext uri="{BB962C8B-B14F-4D97-AF65-F5344CB8AC3E}">
+        <p14:creationId xmlns:p14="http://schemas.microsoft.com/office/powerpoint/2010/main" val="1333598849"/>
       </p:ext>
     </p:extLst>
   </p:cSld>

</xml_diff>